<commit_message>
Remove slide 6 from the presentation deck (now 6 slides)
Co-Authored-By: Claude Sonnet 5.5 <noreply@anthropic.com>
</commit_message>
<xml_diff>
--- a/Docs/One Weapon 발표자료.pptx
+++ b/Docs/One Weapon 발표자료.pptx
@@ -10,7 +10,6 @@
     <p:sldId id="258" r:id="rId10"/>
     <p:sldId id="259" r:id="rId11"/>
     <p:sldId id="260" r:id="rId12"/>
-    <p:sldId id="261" r:id="rId13"/>
     <p:sldId id="262" r:id="rId14"/>
   </p:sldIdLst>
   <p:sldSz cx="12191695" cy="6858000" type="screen4x3"/>
@@ -898,96 +897,6 @@
 </p:notes>
 </file>
 
-<file path=ppt/notesSlides/notesSlide6.xml><?xml version="1.0" encoding="utf-8"?>
-<p:notes xmlns:a="http://schemas.openxmlformats.org/drawingml/2006/main" xmlns:p="http://schemas.openxmlformats.org/presentationml/2006/main" xmlns:r="http://schemas.openxmlformats.org/officeDocument/2006/relationships">
-  <p:cSld>
-    <p:spTree>
-      <p:nvGrpSpPr>
-        <p:cNvPr id="1" name=""/>
-        <p:cNvGrpSpPr/>
-        <p:nvPr/>
-      </p:nvGrpSpPr>
-      <p:grpSpPr>
-        <a:xfrm>
-          <a:off x="0" y="0"/>
-          <a:ext cx="0" cy="0"/>
-          <a:chOff x="0" y="0"/>
-          <a:chExt cx="0" cy="0"/>
-        </a:xfrm>
-      </p:grpSpPr>
-      <p:sp>
-        <p:nvSpPr>
-          <p:cNvPr id="2" name="Slide Image Placeholder 1"/>
-          <p:cNvSpPr>
-            <a:spLocks noGrp="1"/>
-          </p:cNvSpPr>
-          <p:nvPr>
-            <p:ph type="sldImg" idx="2"/>
-          </p:nvPr>
-        </p:nvSpPr>
-        <p:spPr/>
-      </p:sp>
-      <p:sp>
-        <p:nvSpPr>
-          <p:cNvPr id="3" name="Notes Placeholder 2"/>
-          <p:cNvSpPr>
-            <a:spLocks noGrp="1"/>
-          </p:cNvSpPr>
-          <p:nvPr>
-            <p:ph type="body" idx="3" sz="quarter"/>
-          </p:nvPr>
-        </p:nvSpPr>
-        <p:spPr/>
-        <p:txBody>
-          <a:bodyPr/>
-          <a:lstStyle/>
-          <a:p>
-            <a:r>
-              <a:t>[2:55~3:35 / 40초]</a:t>
-            </a:r>
-          </a:p>
-          <a:p>
-            <a:r>
-              <a:t>개발은 MVP, CBT, OBT, 출시의 네 단계로 나눴습니다.</a:t>
-            </a:r>
-          </a:p>
-          <a:p>
-            <a:r>
-              <a:t>MVP는 도형 아트로 던지기, 튕김, 대쉬를 먼저 검증했고, CBT에서 넓은 스테이지와 도트 몬스터, 3D 캐릭터를 넣었습니다. OBT에서는 라운드 반복을 없애고 한 판 클리어형으로 바꾸면서 룬의 동굴, 보스 패턴, 컷신, 타격 이펙트를 만들었어요.</a:t>
-            </a:r>
-          </a:p>
-          <a:p>
-            <a:r>
-              <a:t>먼저 재미를 검증하고 그다음에 외형을 입히는 순서였습니다.</a:t>
-            </a:r>
-          </a:p>
-          <a:p>
-            <a:r>
-              <a:t>도구는 Unity와 GitHub이고, 도트 몬스터와 3D 모델의 초안은 AI 도구 VARCO로 만들어 Blender로 보정했습니다. 구현과 점검에는 Claude Code와 Unity MCP를 썼습니다.</a:t>
-            </a:r>
-          </a:p>
-        </p:txBody>
-      </p:sp>
-      <p:sp>
-        <p:nvSpPr>
-          <p:cNvPr id="4" name="Slide Number Placeholder 3"/>
-          <p:cNvSpPr>
-            <a:spLocks noGrp="1"/>
-          </p:cNvSpPr>
-          <p:nvPr>
-            <p:ph type="sldNum" idx="5" sz="quarter"/>
-          </p:nvPr>
-        </p:nvSpPr>
-        <p:spPr/>
-      </p:sp>
-    </p:spTree>
-  </p:cSld>
-  <p:clrMapOvr>
-    <a:masterClrMapping/>
-  </p:clrMapOvr>
-</p:notes>
-</file>
-
 <file path=ppt/notesSlides/notesSlide7.xml><?xml version="1.0" encoding="utf-8"?>
 <p:notes xmlns:a="http://schemas.openxmlformats.org/drawingml/2006/main" xmlns:p="http://schemas.openxmlformats.org/presentationml/2006/main" xmlns:r="http://schemas.openxmlformats.org/officeDocument/2006/relationships">
   <p:cSld>
@@ -1033,7 +942,7 @@
           <a:lstStyle/>
           <a:p>
             <a:r>
-              <a:t>[3:35~4:10 / 35초]</a:t>
+              <a:t>[2:55~3:30 / 35초]</a:t>
             </a:r>
           </a:p>
           <a:p>
@@ -5035,7 +4944,7 @@
                 <a:ea typeface="맑은 고딕"/>
                 <a:cs typeface="맑은 고딕"/>
               </a:rPr>
-              <a:t>2 / 7</a:t>
+              <a:t>2 / 6</a:t>
             </a:r>
           </a:p>
         </p:txBody>
@@ -6400,7 +6309,7 @@
                 <a:ea typeface="맑은 고딕"/>
                 <a:cs typeface="맑은 고딕"/>
               </a:rPr>
-              <a:t>3 / 7</a:t>
+              <a:t>3 / 6</a:t>
             </a:r>
           </a:p>
         </p:txBody>
@@ -7152,7 +7061,7 @@
                 <a:ea typeface="맑은 고딕"/>
                 <a:cs typeface="맑은 고딕"/>
               </a:rPr>
-              <a:t>4 / 7</a:t>
+              <a:t>4 / 6</a:t>
             </a:r>
           </a:p>
         </p:txBody>
@@ -8034,1342 +7943,7 @@
                 <a:ea typeface="맑은 고딕"/>
                 <a:cs typeface="맑은 고딕"/>
               </a:rPr>
-              <a:t>5 / 7</a:t>
-            </a:r>
-          </a:p>
-        </p:txBody>
-      </p:sp>
-    </p:spTree>
-  </p:cSld>
-  <p:clrMapOvr>
-    <a:masterClrMapping/>
-  </p:clrMapOvr>
-</p:sld>
-</file>
-
-<file path=ppt/slides/slide6.xml><?xml version="1.0" encoding="utf-8"?>
-<p:sld xmlns:a="http://schemas.openxmlformats.org/drawingml/2006/main" xmlns:p="http://schemas.openxmlformats.org/presentationml/2006/main" xmlns:r="http://schemas.openxmlformats.org/officeDocument/2006/relationships">
-  <p:cSld>
-    <p:bg>
-      <p:bgPr>
-        <a:solidFill>
-          <a:srgbClr val="11131A"/>
-        </a:solidFill>
-        <a:effectLst/>
-      </p:bgPr>
-    </p:bg>
-    <p:spTree>
-      <p:nvGrpSpPr>
-        <p:cNvPr id="1" name=""/>
-        <p:cNvGrpSpPr/>
-        <p:nvPr/>
-      </p:nvGrpSpPr>
-      <p:grpSpPr/>
-      <p:sp>
-        <p:nvSpPr>
-          <p:cNvPr id="2" name="Title"/>
-          <p:cNvSpPr txBox="1"/>
-          <p:nvPr/>
-        </p:nvSpPr>
-        <p:spPr>
-          <a:xfrm>
-            <a:off x="640080" y="411480"/>
-            <a:ext cx="10881360" cy="731520"/>
-          </a:xfrm>
-          <a:prstGeom prst="rect">
-            <a:avLst/>
-          </a:prstGeom>
-          <a:noFill/>
-        </p:spPr>
-        <p:txBody>
-          <a:bodyPr wrap="square" lIns="0" rIns="0" tIns="0" bIns="0" anchor="ctr">
-            <a:spAutoFit/>
-          </a:bodyPr>
-          <a:lstStyle/>
-          <a:p>
-            <a:pPr algn="l"/>
-            <a:r>
-              <a:rPr sz="3600" b="1">
-                <a:solidFill>
-                  <a:srgbClr val="FFFFFF"/>
-                </a:solidFill>
-                <a:latin typeface="맑은 고딕"/>
-                <a:ea typeface="맑은 고딕"/>
-                <a:cs typeface="맑은 고딕"/>
-              </a:rPr>
-              <a:t>한 달, 혼자, 4단계</a:t>
-            </a:r>
-          </a:p>
-        </p:txBody>
-      </p:sp>
-      <p:sp>
-        <p:nvSpPr>
-          <p:cNvPr id="3" name="Phase-card-1"/>
-          <p:cNvSpPr/>
-          <p:nvPr/>
-        </p:nvSpPr>
-        <p:spPr>
-          <a:xfrm>
-            <a:off x="640080" y="1417320"/>
-            <a:ext cx="2606040" cy="2743200"/>
-          </a:xfrm>
-          <a:prstGeom prst="roundRect">
-            <a:avLst>
-              <a:gd name="adj" fmla="val 5263"/>
-            </a:avLst>
-          </a:prstGeom>
-          <a:solidFill>
-            <a:srgbClr val="1C2030"/>
-          </a:solidFill>
-          <a:ln>
-            <a:noFill/>
-          </a:ln>
-          <a:effectLst/>
-        </p:spPr>
-        <p:style>
-          <a:lnRef idx="1">
-            <a:schemeClr val="accent1"/>
-          </a:lnRef>
-          <a:fillRef idx="3">
-            <a:schemeClr val="accent1"/>
-          </a:fillRef>
-          <a:effectRef idx="2">
-            <a:schemeClr val="accent1"/>
-          </a:effectRef>
-          <a:fontRef idx="minor">
-            <a:schemeClr val="lt1"/>
-          </a:fontRef>
-        </p:style>
-        <p:txBody>
-          <a:bodyPr rtlCol="0" anchor="ctr"/>
-          <a:lstStyle/>
-          <a:p>
-            <a:pPr algn="ctr"/>
-          </a:p>
-        </p:txBody>
-      </p:sp>
-      <p:sp>
-        <p:nvSpPr>
-          <p:cNvPr id="4" name="Phase-name-1"/>
-          <p:cNvSpPr txBox="1"/>
-          <p:nvPr/>
-        </p:nvSpPr>
-        <p:spPr>
-          <a:xfrm>
-            <a:off x="868680" y="1572768"/>
-            <a:ext cx="2148840" cy="548640"/>
-          </a:xfrm>
-          <a:prstGeom prst="rect">
-            <a:avLst/>
-          </a:prstGeom>
-          <a:noFill/>
-        </p:spPr>
-        <p:txBody>
-          <a:bodyPr wrap="square" lIns="0" rIns="0" tIns="0" bIns="0" anchor="t">
-            <a:spAutoFit/>
-          </a:bodyPr>
-          <a:lstStyle/>
-          <a:p>
-            <a:pPr algn="l"/>
-            <a:r>
-              <a:rPr sz="2800" b="1">
-                <a:solidFill>
-                  <a:srgbClr val="5EC8DA"/>
-                </a:solidFill>
-                <a:latin typeface="맑은 고딕"/>
-                <a:ea typeface="맑은 고딕"/>
-                <a:cs typeface="맑은 고딕"/>
-              </a:rPr>
-              <a:t>MVP</a:t>
-            </a:r>
-          </a:p>
-        </p:txBody>
-      </p:sp>
-      <p:sp>
-        <p:nvSpPr>
-          <p:cNvPr id="5" name="Phase-date-1"/>
-          <p:cNvSpPr txBox="1"/>
-          <p:nvPr/>
-        </p:nvSpPr>
-        <p:spPr>
-          <a:xfrm>
-            <a:off x="868680" y="2103120"/>
-            <a:ext cx="2148840" cy="320040"/>
-          </a:xfrm>
-          <a:prstGeom prst="rect">
-            <a:avLst/>
-          </a:prstGeom>
-          <a:noFill/>
-        </p:spPr>
-        <p:txBody>
-          <a:bodyPr wrap="square" lIns="0" rIns="0" tIns="0" bIns="0" anchor="t">
-            <a:spAutoFit/>
-          </a:bodyPr>
-          <a:lstStyle/>
-          <a:p>
-            <a:pPr algn="l"/>
-            <a:r>
-              <a:rPr sz="1400" b="0">
-                <a:solidFill>
-                  <a:srgbClr val="A3ABBD"/>
-                </a:solidFill>
-                <a:latin typeface="맑은 고딕"/>
-                <a:ea typeface="맑은 고딕"/>
-                <a:cs typeface="맑은 고딕"/>
-              </a:rPr>
-              <a:t>10/8</a:t>
-            </a:r>
-          </a:p>
-        </p:txBody>
-      </p:sp>
-      <p:sp>
-        <p:nvSpPr>
-          <p:cNvPr id="6" name="Rounded Rectangle 5"/>
-          <p:cNvSpPr/>
-          <p:nvPr/>
-        </p:nvSpPr>
-        <p:spPr>
-          <a:xfrm>
-            <a:off x="868680" y="2514600"/>
-            <a:ext cx="695960" cy="329184"/>
-          </a:xfrm>
-          <a:prstGeom prst="roundRect">
-            <a:avLst>
-              <a:gd name="adj" fmla="val 50000"/>
-            </a:avLst>
-          </a:prstGeom>
-          <a:solidFill>
-            <a:srgbClr val="5EC8DA"/>
-          </a:solidFill>
-          <a:ln>
-            <a:noFill/>
-          </a:ln>
-          <a:effectLst/>
-        </p:spPr>
-        <p:style>
-          <a:lnRef idx="1">
-            <a:schemeClr val="accent1"/>
-          </a:lnRef>
-          <a:fillRef idx="3">
-            <a:schemeClr val="accent1"/>
-          </a:fillRef>
-          <a:effectRef idx="2">
-            <a:schemeClr val="accent1"/>
-          </a:effectRef>
-          <a:fontRef idx="minor">
-            <a:schemeClr val="lt1"/>
-          </a:fontRef>
-        </p:style>
-        <p:txBody>
-          <a:bodyPr rtlCol="0" anchor="ctr" lIns="0" rIns="0" tIns="0" bIns="0" wrap="none"/>
-          <a:lstStyle/>
-          <a:p>
-            <a:pPr algn="ctr"/>
-            <a:r>
-              <a:rPr sz="1300">
-                <a:solidFill>
-                  <a:srgbClr val="11131A"/>
-                </a:solidFill>
-                <a:latin typeface="맑은 고딕"/>
-                <a:ea typeface="맑은 고딕"/>
-                <a:cs typeface="맑은 고딕"/>
-              </a:rPr>
-              <a:t>완료</a:t>
-            </a:r>
-          </a:p>
-        </p:txBody>
-      </p:sp>
-      <p:sp>
-        <p:nvSpPr>
-          <p:cNvPr id="7" name="Phase-desc-1"/>
-          <p:cNvSpPr txBox="1"/>
-          <p:nvPr/>
-        </p:nvSpPr>
-        <p:spPr>
-          <a:xfrm>
-            <a:off x="868680" y="3017520"/>
-            <a:ext cx="2148840" cy="1097280"/>
-          </a:xfrm>
-          <a:prstGeom prst="rect">
-            <a:avLst/>
-          </a:prstGeom>
-          <a:noFill/>
-        </p:spPr>
-        <p:txBody>
-          <a:bodyPr wrap="square" lIns="0" rIns="0" tIns="0" bIns="0" anchor="t">
-            <a:spAutoFit/>
-          </a:bodyPr>
-          <a:lstStyle/>
-          <a:p>
-            <a:pPr algn="l"/>
-            <a:r>
-              <a:rPr sz="1400" b="0">
-                <a:solidFill>
-                  <a:srgbClr val="FFFFFF"/>
-                </a:solidFill>
-                <a:latin typeface="맑은 고딕"/>
-                <a:ea typeface="맑은 고딕"/>
-                <a:cs typeface="맑은 고딕"/>
-              </a:rPr>
-              <a:t>던지기·튕김·대쉬, 라운드 반복, 회수 스킬. 도형 아트로 재미부터 검증</a:t>
-            </a:r>
-          </a:p>
-        </p:txBody>
-      </p:sp>
-      <p:sp>
-        <p:nvSpPr>
-          <p:cNvPr id="8" name="Phase-card-2"/>
-          <p:cNvSpPr/>
-          <p:nvPr/>
-        </p:nvSpPr>
-        <p:spPr>
-          <a:xfrm>
-            <a:off x="3429000" y="1417320"/>
-            <a:ext cx="2606040" cy="2743200"/>
-          </a:xfrm>
-          <a:prstGeom prst="roundRect">
-            <a:avLst>
-              <a:gd name="adj" fmla="val 5263"/>
-            </a:avLst>
-          </a:prstGeom>
-          <a:solidFill>
-            <a:srgbClr val="1C2030"/>
-          </a:solidFill>
-          <a:ln>
-            <a:noFill/>
-          </a:ln>
-          <a:effectLst/>
-        </p:spPr>
-        <p:style>
-          <a:lnRef idx="1">
-            <a:schemeClr val="accent1"/>
-          </a:lnRef>
-          <a:fillRef idx="3">
-            <a:schemeClr val="accent1"/>
-          </a:fillRef>
-          <a:effectRef idx="2">
-            <a:schemeClr val="accent1"/>
-          </a:effectRef>
-          <a:fontRef idx="minor">
-            <a:schemeClr val="lt1"/>
-          </a:fontRef>
-        </p:style>
-        <p:txBody>
-          <a:bodyPr rtlCol="0" anchor="ctr"/>
-          <a:lstStyle/>
-          <a:p>
-            <a:pPr algn="ctr"/>
-          </a:p>
-        </p:txBody>
-      </p:sp>
-      <p:sp>
-        <p:nvSpPr>
-          <p:cNvPr id="9" name="Phase-name-2"/>
-          <p:cNvSpPr txBox="1"/>
-          <p:nvPr/>
-        </p:nvSpPr>
-        <p:spPr>
-          <a:xfrm>
-            <a:off x="3657600" y="1572768"/>
-            <a:ext cx="2148840" cy="548640"/>
-          </a:xfrm>
-          <a:prstGeom prst="rect">
-            <a:avLst/>
-          </a:prstGeom>
-          <a:noFill/>
-        </p:spPr>
-        <p:txBody>
-          <a:bodyPr wrap="square" lIns="0" rIns="0" tIns="0" bIns="0" anchor="t">
-            <a:spAutoFit/>
-          </a:bodyPr>
-          <a:lstStyle/>
-          <a:p>
-            <a:pPr algn="l"/>
-            <a:r>
-              <a:rPr sz="2800" b="1">
-                <a:solidFill>
-                  <a:srgbClr val="5EC8DA"/>
-                </a:solidFill>
-                <a:latin typeface="맑은 고딕"/>
-                <a:ea typeface="맑은 고딕"/>
-                <a:cs typeface="맑은 고딕"/>
-              </a:rPr>
-              <a:t>CBT</a:t>
-            </a:r>
-          </a:p>
-        </p:txBody>
-      </p:sp>
-      <p:sp>
-        <p:nvSpPr>
-          <p:cNvPr id="10" name="Phase-date-2"/>
-          <p:cNvSpPr txBox="1"/>
-          <p:nvPr/>
-        </p:nvSpPr>
-        <p:spPr>
-          <a:xfrm>
-            <a:off x="3657600" y="2103120"/>
-            <a:ext cx="2148840" cy="320040"/>
-          </a:xfrm>
-          <a:prstGeom prst="rect">
-            <a:avLst/>
-          </a:prstGeom>
-          <a:noFill/>
-        </p:spPr>
-        <p:txBody>
-          <a:bodyPr wrap="square" lIns="0" rIns="0" tIns="0" bIns="0" anchor="t">
-            <a:spAutoFit/>
-          </a:bodyPr>
-          <a:lstStyle/>
-          <a:p>
-            <a:pPr algn="l"/>
-            <a:r>
-              <a:rPr sz="1400" b="0">
-                <a:solidFill>
-                  <a:srgbClr val="A3ABBD"/>
-                </a:solidFill>
-                <a:latin typeface="맑은 고딕"/>
-                <a:ea typeface="맑은 고딕"/>
-                <a:cs typeface="맑은 고딕"/>
-              </a:rPr>
-              <a:t>10/9 – 10/16</a:t>
-            </a:r>
-          </a:p>
-        </p:txBody>
-      </p:sp>
-      <p:sp>
-        <p:nvSpPr>
-          <p:cNvPr id="11" name="Rounded Rectangle 10"/>
-          <p:cNvSpPr/>
-          <p:nvPr/>
-        </p:nvSpPr>
-        <p:spPr>
-          <a:xfrm>
-            <a:off x="3657600" y="2514600"/>
-            <a:ext cx="695960" cy="329184"/>
-          </a:xfrm>
-          <a:prstGeom prst="roundRect">
-            <a:avLst>
-              <a:gd name="adj" fmla="val 50000"/>
-            </a:avLst>
-          </a:prstGeom>
-          <a:solidFill>
-            <a:srgbClr val="5EC8DA"/>
-          </a:solidFill>
-          <a:ln>
-            <a:noFill/>
-          </a:ln>
-          <a:effectLst/>
-        </p:spPr>
-        <p:style>
-          <a:lnRef idx="1">
-            <a:schemeClr val="accent1"/>
-          </a:lnRef>
-          <a:fillRef idx="3">
-            <a:schemeClr val="accent1"/>
-          </a:fillRef>
-          <a:effectRef idx="2">
-            <a:schemeClr val="accent1"/>
-          </a:effectRef>
-          <a:fontRef idx="minor">
-            <a:schemeClr val="lt1"/>
-          </a:fontRef>
-        </p:style>
-        <p:txBody>
-          <a:bodyPr rtlCol="0" anchor="ctr" lIns="0" rIns="0" tIns="0" bIns="0" wrap="none"/>
-          <a:lstStyle/>
-          <a:p>
-            <a:pPr algn="ctr"/>
-            <a:r>
-              <a:rPr sz="1300">
-                <a:solidFill>
-                  <a:srgbClr val="11131A"/>
-                </a:solidFill>
-                <a:latin typeface="맑은 고딕"/>
-                <a:ea typeface="맑은 고딕"/>
-                <a:cs typeface="맑은 고딕"/>
-              </a:rPr>
-              <a:t>완료</a:t>
-            </a:r>
-          </a:p>
-        </p:txBody>
-      </p:sp>
-      <p:sp>
-        <p:nvSpPr>
-          <p:cNvPr id="12" name="Phase-desc-2"/>
-          <p:cNvSpPr txBox="1"/>
-          <p:nvPr/>
-        </p:nvSpPr>
-        <p:spPr>
-          <a:xfrm>
-            <a:off x="3657600" y="3017520"/>
-            <a:ext cx="2148840" cy="1097280"/>
-          </a:xfrm>
-          <a:prstGeom prst="rect">
-            <a:avLst/>
-          </a:prstGeom>
-          <a:noFill/>
-        </p:spPr>
-        <p:txBody>
-          <a:bodyPr wrap="square" lIns="0" rIns="0" tIns="0" bIns="0" anchor="t">
-            <a:spAutoFit/>
-          </a:bodyPr>
-          <a:lstStyle/>
-          <a:p>
-            <a:pPr algn="l"/>
-            <a:r>
-              <a:rPr sz="1400" b="0">
-                <a:solidFill>
-                  <a:srgbClr val="FFFFFF"/>
-                </a:solidFill>
-                <a:latin typeface="맑은 고딕"/>
-                <a:ea typeface="맑은 고딕"/>
-                <a:cs typeface="맑은 고딕"/>
-              </a:rPr>
-              <a:t>넓은 스테이지 맵, 도트 몬스터, 3D 캐릭터와 단검</a:t>
-            </a:r>
-          </a:p>
-        </p:txBody>
-      </p:sp>
-      <p:sp>
-        <p:nvSpPr>
-          <p:cNvPr id="13" name="Phase-card-3"/>
-          <p:cNvSpPr/>
-          <p:nvPr/>
-        </p:nvSpPr>
-        <p:spPr>
-          <a:xfrm>
-            <a:off x="6217920" y="1417320"/>
-            <a:ext cx="2606040" cy="2743200"/>
-          </a:xfrm>
-          <a:prstGeom prst="roundRect">
-            <a:avLst>
-              <a:gd name="adj" fmla="val 5263"/>
-            </a:avLst>
-          </a:prstGeom>
-          <a:solidFill>
-            <a:srgbClr val="1C2030"/>
-          </a:solidFill>
-          <a:ln>
-            <a:noFill/>
-          </a:ln>
-          <a:effectLst/>
-        </p:spPr>
-        <p:style>
-          <a:lnRef idx="1">
-            <a:schemeClr val="accent1"/>
-          </a:lnRef>
-          <a:fillRef idx="3">
-            <a:schemeClr val="accent1"/>
-          </a:fillRef>
-          <a:effectRef idx="2">
-            <a:schemeClr val="accent1"/>
-          </a:effectRef>
-          <a:fontRef idx="minor">
-            <a:schemeClr val="lt1"/>
-          </a:fontRef>
-        </p:style>
-        <p:txBody>
-          <a:bodyPr rtlCol="0" anchor="ctr"/>
-          <a:lstStyle/>
-          <a:p>
-            <a:pPr algn="ctr"/>
-          </a:p>
-        </p:txBody>
-      </p:sp>
-      <p:sp>
-        <p:nvSpPr>
-          <p:cNvPr id="14" name="Phase-name-3"/>
-          <p:cNvSpPr txBox="1"/>
-          <p:nvPr/>
-        </p:nvSpPr>
-        <p:spPr>
-          <a:xfrm>
-            <a:off x="6446520" y="1572768"/>
-            <a:ext cx="2148840" cy="548640"/>
-          </a:xfrm>
-          <a:prstGeom prst="rect">
-            <a:avLst/>
-          </a:prstGeom>
-          <a:noFill/>
-        </p:spPr>
-        <p:txBody>
-          <a:bodyPr wrap="square" lIns="0" rIns="0" tIns="0" bIns="0" anchor="t">
-            <a:spAutoFit/>
-          </a:bodyPr>
-          <a:lstStyle/>
-          <a:p>
-            <a:pPr algn="l"/>
-            <a:r>
-              <a:rPr sz="2800" b="1">
-                <a:solidFill>
-                  <a:srgbClr val="5EC8DA"/>
-                </a:solidFill>
-                <a:latin typeface="맑은 고딕"/>
-                <a:ea typeface="맑은 고딕"/>
-                <a:cs typeface="맑은 고딕"/>
-              </a:rPr>
-              <a:t>OBT</a:t>
-            </a:r>
-          </a:p>
-        </p:txBody>
-      </p:sp>
-      <p:sp>
-        <p:nvSpPr>
-          <p:cNvPr id="15" name="Phase-date-3"/>
-          <p:cNvSpPr txBox="1"/>
-          <p:nvPr/>
-        </p:nvSpPr>
-        <p:spPr>
-          <a:xfrm>
-            <a:off x="6446520" y="2103120"/>
-            <a:ext cx="2148840" cy="320040"/>
-          </a:xfrm>
-          <a:prstGeom prst="rect">
-            <a:avLst/>
-          </a:prstGeom>
-          <a:noFill/>
-        </p:spPr>
-        <p:txBody>
-          <a:bodyPr wrap="square" lIns="0" rIns="0" tIns="0" bIns="0" anchor="t">
-            <a:spAutoFit/>
-          </a:bodyPr>
-          <a:lstStyle/>
-          <a:p>
-            <a:pPr algn="l"/>
-            <a:r>
-              <a:rPr sz="1400" b="0">
-                <a:solidFill>
-                  <a:srgbClr val="A3ABBD"/>
-                </a:solidFill>
-                <a:latin typeface="맑은 고딕"/>
-                <a:ea typeface="맑은 고딕"/>
-                <a:cs typeface="맑은 고딕"/>
-              </a:rPr>
-              <a:t>10/17 – 10/24</a:t>
-            </a:r>
-          </a:p>
-        </p:txBody>
-      </p:sp>
-      <p:sp>
-        <p:nvSpPr>
-          <p:cNvPr id="16" name="Rounded Rectangle 15"/>
-          <p:cNvSpPr/>
-          <p:nvPr/>
-        </p:nvSpPr>
-        <p:spPr>
-          <a:xfrm>
-            <a:off x="6446520" y="2514600"/>
-            <a:ext cx="695960" cy="329184"/>
-          </a:xfrm>
-          <a:prstGeom prst="roundRect">
-            <a:avLst>
-              <a:gd name="adj" fmla="val 50000"/>
-            </a:avLst>
-          </a:prstGeom>
-          <a:solidFill>
-            <a:srgbClr val="5EC8DA"/>
-          </a:solidFill>
-          <a:ln>
-            <a:noFill/>
-          </a:ln>
-          <a:effectLst/>
-        </p:spPr>
-        <p:style>
-          <a:lnRef idx="1">
-            <a:schemeClr val="accent1"/>
-          </a:lnRef>
-          <a:fillRef idx="3">
-            <a:schemeClr val="accent1"/>
-          </a:fillRef>
-          <a:effectRef idx="2">
-            <a:schemeClr val="accent1"/>
-          </a:effectRef>
-          <a:fontRef idx="minor">
-            <a:schemeClr val="lt1"/>
-          </a:fontRef>
-        </p:style>
-        <p:txBody>
-          <a:bodyPr rtlCol="0" anchor="ctr" lIns="0" rIns="0" tIns="0" bIns="0" wrap="none"/>
-          <a:lstStyle/>
-          <a:p>
-            <a:pPr algn="ctr"/>
-            <a:r>
-              <a:rPr sz="1300">
-                <a:solidFill>
-                  <a:srgbClr val="11131A"/>
-                </a:solidFill>
-                <a:latin typeface="맑은 고딕"/>
-                <a:ea typeface="맑은 고딕"/>
-                <a:cs typeface="맑은 고딕"/>
-              </a:rPr>
-              <a:t>완료</a:t>
-            </a:r>
-          </a:p>
-        </p:txBody>
-      </p:sp>
-      <p:sp>
-        <p:nvSpPr>
-          <p:cNvPr id="17" name="Phase-desc-3"/>
-          <p:cNvSpPr txBox="1"/>
-          <p:nvPr/>
-        </p:nvSpPr>
-        <p:spPr>
-          <a:xfrm>
-            <a:off x="6446520" y="3017520"/>
-            <a:ext cx="2148840" cy="1097280"/>
-          </a:xfrm>
-          <a:prstGeom prst="rect">
-            <a:avLst/>
-          </a:prstGeom>
-          <a:noFill/>
-        </p:spPr>
-        <p:txBody>
-          <a:bodyPr wrap="square" lIns="0" rIns="0" tIns="0" bIns="0" anchor="t">
-            <a:spAutoFit/>
-          </a:bodyPr>
-          <a:lstStyle/>
-          <a:p>
-            <a:pPr algn="l"/>
-            <a:r>
-              <a:rPr sz="1400" b="0">
-                <a:solidFill>
-                  <a:srgbClr val="FFFFFF"/>
-                </a:solidFill>
-                <a:latin typeface="맑은 고딕"/>
-                <a:ea typeface="맑은 고딕"/>
-                <a:cs typeface="맑은 고딕"/>
-              </a:rPr>
-              <a:t>한 판 클리어형으로 정리. 룬의 동굴, 보스 패턴·컷신, 타격 이펙트</a:t>
-            </a:r>
-          </a:p>
-        </p:txBody>
-      </p:sp>
-      <p:sp>
-        <p:nvSpPr>
-          <p:cNvPr id="18" name="Phase-card-4"/>
-          <p:cNvSpPr/>
-          <p:nvPr/>
-        </p:nvSpPr>
-        <p:spPr>
-          <a:xfrm>
-            <a:off x="9006840" y="1417320"/>
-            <a:ext cx="2606040" cy="2743200"/>
-          </a:xfrm>
-          <a:prstGeom prst="roundRect">
-            <a:avLst>
-              <a:gd name="adj" fmla="val 5263"/>
-            </a:avLst>
-          </a:prstGeom>
-          <a:solidFill>
-            <a:srgbClr val="1C2030"/>
-          </a:solidFill>
-          <a:ln>
-            <a:noFill/>
-          </a:ln>
-          <a:effectLst/>
-        </p:spPr>
-        <p:style>
-          <a:lnRef idx="1">
-            <a:schemeClr val="accent1"/>
-          </a:lnRef>
-          <a:fillRef idx="3">
-            <a:schemeClr val="accent1"/>
-          </a:fillRef>
-          <a:effectRef idx="2">
-            <a:schemeClr val="accent1"/>
-          </a:effectRef>
-          <a:fontRef idx="minor">
-            <a:schemeClr val="lt1"/>
-          </a:fontRef>
-        </p:style>
-        <p:txBody>
-          <a:bodyPr rtlCol="0" anchor="ctr"/>
-          <a:lstStyle/>
-          <a:p>
-            <a:pPr algn="ctr"/>
-          </a:p>
-        </p:txBody>
-      </p:sp>
-      <p:sp>
-        <p:nvSpPr>
-          <p:cNvPr id="19" name="Phase-name-4"/>
-          <p:cNvSpPr txBox="1"/>
-          <p:nvPr/>
-        </p:nvSpPr>
-        <p:spPr>
-          <a:xfrm>
-            <a:off x="9235440" y="1572768"/>
-            <a:ext cx="2148840" cy="548640"/>
-          </a:xfrm>
-          <a:prstGeom prst="rect">
-            <a:avLst/>
-          </a:prstGeom>
-          <a:noFill/>
-        </p:spPr>
-        <p:txBody>
-          <a:bodyPr wrap="square" lIns="0" rIns="0" tIns="0" bIns="0" anchor="t">
-            <a:spAutoFit/>
-          </a:bodyPr>
-          <a:lstStyle/>
-          <a:p>
-            <a:pPr algn="l"/>
-            <a:r>
-              <a:rPr sz="2800" b="1">
-                <a:solidFill>
-                  <a:srgbClr val="E3A82B"/>
-                </a:solidFill>
-                <a:latin typeface="맑은 고딕"/>
-                <a:ea typeface="맑은 고딕"/>
-                <a:cs typeface="맑은 고딕"/>
-              </a:rPr>
-              <a:t>출시</a:t>
-            </a:r>
-          </a:p>
-        </p:txBody>
-      </p:sp>
-      <p:sp>
-        <p:nvSpPr>
-          <p:cNvPr id="20" name="Phase-date-4"/>
-          <p:cNvSpPr txBox="1"/>
-          <p:nvPr/>
-        </p:nvSpPr>
-        <p:spPr>
-          <a:xfrm>
-            <a:off x="9235440" y="2103120"/>
-            <a:ext cx="2148840" cy="320040"/>
-          </a:xfrm>
-          <a:prstGeom prst="rect">
-            <a:avLst/>
-          </a:prstGeom>
-          <a:noFill/>
-        </p:spPr>
-        <p:txBody>
-          <a:bodyPr wrap="square" lIns="0" rIns="0" tIns="0" bIns="0" anchor="t">
-            <a:spAutoFit/>
-          </a:bodyPr>
-          <a:lstStyle/>
-          <a:p>
-            <a:pPr algn="l"/>
-            <a:r>
-              <a:rPr sz="1400" b="0">
-                <a:solidFill>
-                  <a:srgbClr val="A3ABBD"/>
-                </a:solidFill>
-                <a:latin typeface="맑은 고딕"/>
-                <a:ea typeface="맑은 고딕"/>
-                <a:cs typeface="맑은 고딕"/>
-              </a:rPr>
-              <a:t>10/25 – 10/28</a:t>
-            </a:r>
-          </a:p>
-        </p:txBody>
-      </p:sp>
-      <p:sp>
-        <p:nvSpPr>
-          <p:cNvPr id="21" name="Rounded Rectangle 20"/>
-          <p:cNvSpPr/>
-          <p:nvPr/>
-        </p:nvSpPr>
-        <p:spPr>
-          <a:xfrm>
-            <a:off x="9235440" y="2514600"/>
-            <a:ext cx="951865" cy="329184"/>
-          </a:xfrm>
-          <a:prstGeom prst="roundRect">
-            <a:avLst>
-              <a:gd name="adj" fmla="val 50000"/>
-            </a:avLst>
-          </a:prstGeom>
-          <a:solidFill>
-            <a:srgbClr val="E3A82B"/>
-          </a:solidFill>
-          <a:ln>
-            <a:noFill/>
-          </a:ln>
-          <a:effectLst/>
-        </p:spPr>
-        <p:style>
-          <a:lnRef idx="1">
-            <a:schemeClr val="accent1"/>
-          </a:lnRef>
-          <a:fillRef idx="3">
-            <a:schemeClr val="accent1"/>
-          </a:fillRef>
-          <a:effectRef idx="2">
-            <a:schemeClr val="accent1"/>
-          </a:effectRef>
-          <a:fontRef idx="minor">
-            <a:schemeClr val="lt1"/>
-          </a:fontRef>
-        </p:style>
-        <p:txBody>
-          <a:bodyPr rtlCol="0" anchor="ctr" lIns="0" rIns="0" tIns="0" bIns="0" wrap="none"/>
-          <a:lstStyle/>
-          <a:p>
-            <a:pPr algn="ctr"/>
-            <a:r>
-              <a:rPr sz="1300">
-                <a:solidFill>
-                  <a:srgbClr val="11131A"/>
-                </a:solidFill>
-                <a:latin typeface="맑은 고딕"/>
-                <a:ea typeface="맑은 고딕"/>
-                <a:cs typeface="맑은 고딕"/>
-              </a:rPr>
-              <a:t>진행 중</a:t>
-            </a:r>
-          </a:p>
-        </p:txBody>
-      </p:sp>
-      <p:sp>
-        <p:nvSpPr>
-          <p:cNvPr id="22" name="Phase-desc-4"/>
-          <p:cNvSpPr txBox="1"/>
-          <p:nvPr/>
-        </p:nvSpPr>
-        <p:spPr>
-          <a:xfrm>
-            <a:off x="9235440" y="3017520"/>
-            <a:ext cx="2148840" cy="1097280"/>
-          </a:xfrm>
-          <a:prstGeom prst="rect">
-            <a:avLst/>
-          </a:prstGeom>
-          <a:noFill/>
-        </p:spPr>
-        <p:txBody>
-          <a:bodyPr wrap="square" lIns="0" rIns="0" tIns="0" bIns="0" anchor="t">
-            <a:spAutoFit/>
-          </a:bodyPr>
-          <a:lstStyle/>
-          <a:p>
-            <a:pPr algn="l"/>
-            <a:r>
-              <a:rPr sz="1400" b="0">
-                <a:solidFill>
-                  <a:srgbClr val="FFFFFF"/>
-                </a:solidFill>
-                <a:latin typeface="맑은 고딕"/>
-                <a:ea typeface="맑은 고딕"/>
-                <a:cs typeface="맑은 고딕"/>
-              </a:rPr>
-              <a:t>빌드 안정화와 시연 동선 정리. 효과음은 시간이 남으면</a:t>
-            </a:r>
-          </a:p>
-        </p:txBody>
-      </p:sp>
-      <p:sp>
-        <p:nvSpPr>
-          <p:cNvPr id="23" name="Tools-label"/>
-          <p:cNvSpPr txBox="1"/>
-          <p:nvPr/>
-        </p:nvSpPr>
-        <p:spPr>
-          <a:xfrm>
-            <a:off x="640080" y="4480560"/>
-            <a:ext cx="3657600" cy="274320"/>
-          </a:xfrm>
-          <a:prstGeom prst="rect">
-            <a:avLst/>
-          </a:prstGeom>
-          <a:noFill/>
-        </p:spPr>
-        <p:txBody>
-          <a:bodyPr wrap="square" lIns="0" rIns="0" tIns="0" bIns="0" anchor="t">
-            <a:spAutoFit/>
-          </a:bodyPr>
-          <a:lstStyle/>
-          <a:p>
-            <a:pPr algn="l"/>
-            <a:r>
-              <a:rPr sz="1400" b="1">
-                <a:solidFill>
-                  <a:srgbClr val="E3A82B"/>
-                </a:solidFill>
-                <a:latin typeface="맑은 고딕"/>
-                <a:ea typeface="맑은 고딕"/>
-                <a:cs typeface="맑은 고딕"/>
-              </a:rPr>
-              <a:t>사용한 도구</a:t>
-            </a:r>
-          </a:p>
-        </p:txBody>
-      </p:sp>
-      <p:sp>
-        <p:nvSpPr>
-          <p:cNvPr id="24" name="Rounded Rectangle 23"/>
-          <p:cNvSpPr/>
-          <p:nvPr/>
-        </p:nvSpPr>
-        <p:spPr>
-          <a:xfrm>
-            <a:off x="640080" y="4846320"/>
-            <a:ext cx="1783334" cy="420624"/>
-          </a:xfrm>
-          <a:prstGeom prst="roundRect">
-            <a:avLst>
-              <a:gd name="adj" fmla="val 50000"/>
-            </a:avLst>
-          </a:prstGeom>
-          <a:solidFill>
-            <a:srgbClr val="262B3F"/>
-          </a:solidFill>
-          <a:ln>
-            <a:noFill/>
-          </a:ln>
-          <a:effectLst/>
-        </p:spPr>
-        <p:style>
-          <a:lnRef idx="1">
-            <a:schemeClr val="accent1"/>
-          </a:lnRef>
-          <a:fillRef idx="3">
-            <a:schemeClr val="accent1"/>
-          </a:fillRef>
-          <a:effectRef idx="2">
-            <a:schemeClr val="accent1"/>
-          </a:effectRef>
-          <a:fontRef idx="minor">
-            <a:schemeClr val="lt1"/>
-          </a:fontRef>
-        </p:style>
-        <p:txBody>
-          <a:bodyPr rtlCol="0" anchor="ctr" lIns="0" rIns="0" tIns="0" bIns="0" wrap="none"/>
-          <a:lstStyle/>
-          <a:p>
-            <a:pPr algn="ctr"/>
-            <a:r>
-              <a:rPr sz="1400">
-                <a:solidFill>
-                  <a:srgbClr val="FFFFFF"/>
-                </a:solidFill>
-                <a:latin typeface="맑은 고딕"/>
-                <a:ea typeface="맑은 고딕"/>
-                <a:cs typeface="맑은 고딕"/>
-              </a:rPr>
-              <a:t>Unity 6 · URP</a:t>
-            </a:r>
-          </a:p>
-        </p:txBody>
-      </p:sp>
-      <p:sp>
-        <p:nvSpPr>
-          <p:cNvPr id="25" name="Rounded Rectangle 24"/>
-          <p:cNvSpPr/>
-          <p:nvPr/>
-        </p:nvSpPr>
-        <p:spPr>
-          <a:xfrm>
-            <a:off x="2560574" y="4846320"/>
-            <a:ext cx="1685544" cy="420624"/>
-          </a:xfrm>
-          <a:prstGeom prst="roundRect">
-            <a:avLst>
-              <a:gd name="adj" fmla="val 50000"/>
-            </a:avLst>
-          </a:prstGeom>
-          <a:solidFill>
-            <a:srgbClr val="262B3F"/>
-          </a:solidFill>
-          <a:ln>
-            <a:noFill/>
-          </a:ln>
-          <a:effectLst/>
-        </p:spPr>
-        <p:style>
-          <a:lnRef idx="1">
-            <a:schemeClr val="accent1"/>
-          </a:lnRef>
-          <a:fillRef idx="3">
-            <a:schemeClr val="accent1"/>
-          </a:fillRef>
-          <a:effectRef idx="2">
-            <a:schemeClr val="accent1"/>
-          </a:effectRef>
-          <a:fontRef idx="minor">
-            <a:schemeClr val="lt1"/>
-          </a:fontRef>
-        </p:style>
-        <p:txBody>
-          <a:bodyPr rtlCol="0" anchor="ctr" lIns="0" rIns="0" tIns="0" bIns="0" wrap="none"/>
-          <a:lstStyle/>
-          <a:p>
-            <a:pPr algn="ctr"/>
-            <a:r>
-              <a:rPr sz="1400">
-                <a:solidFill>
-                  <a:srgbClr val="FFFFFF"/>
-                </a:solidFill>
-                <a:latin typeface="맑은 고딕"/>
-                <a:ea typeface="맑은 고딕"/>
-                <a:cs typeface="맑은 고딕"/>
-              </a:rPr>
-              <a:t>Input System</a:t>
-            </a:r>
-          </a:p>
-        </p:txBody>
-      </p:sp>
-      <p:sp>
-        <p:nvSpPr>
-          <p:cNvPr id="26" name="Rounded Rectangle 25"/>
-          <p:cNvSpPr/>
-          <p:nvPr/>
-        </p:nvSpPr>
-        <p:spPr>
-          <a:xfrm>
-            <a:off x="4383278" y="4846320"/>
-            <a:ext cx="2690114" cy="420624"/>
-          </a:xfrm>
-          <a:prstGeom prst="roundRect">
-            <a:avLst>
-              <a:gd name="adj" fmla="val 50000"/>
-            </a:avLst>
-          </a:prstGeom>
-          <a:solidFill>
-            <a:srgbClr val="262B3F"/>
-          </a:solidFill>
-          <a:ln>
-            <a:noFill/>
-          </a:ln>
-          <a:effectLst/>
-        </p:spPr>
-        <p:style>
-          <a:lnRef idx="1">
-            <a:schemeClr val="accent1"/>
-          </a:lnRef>
-          <a:fillRef idx="3">
-            <a:schemeClr val="accent1"/>
-          </a:fillRef>
-          <a:effectRef idx="2">
-            <a:schemeClr val="accent1"/>
-          </a:effectRef>
-          <a:fontRef idx="minor">
-            <a:schemeClr val="lt1"/>
-          </a:fontRef>
-        </p:style>
-        <p:txBody>
-          <a:bodyPr rtlCol="0" anchor="ctr" lIns="0" rIns="0" tIns="0" bIns="0" wrap="none"/>
-          <a:lstStyle/>
-          <a:p>
-            <a:pPr algn="ctr"/>
-            <a:r>
-              <a:rPr sz="1400">
-                <a:solidFill>
-                  <a:srgbClr val="FFFFFF"/>
-                </a:solidFill>
-                <a:latin typeface="맑은 고딕"/>
-                <a:ea typeface="맑은 고딕"/>
-                <a:cs typeface="맑은 고딕"/>
-              </a:rPr>
-              <a:t>VARCO · AI 도트/3D 초안</a:t>
-            </a:r>
-          </a:p>
-        </p:txBody>
-      </p:sp>
-      <p:sp>
-        <p:nvSpPr>
-          <p:cNvPr id="27" name="Rounded Rectangle 26"/>
-          <p:cNvSpPr/>
-          <p:nvPr/>
-        </p:nvSpPr>
-        <p:spPr>
-          <a:xfrm>
-            <a:off x="7210552" y="4846320"/>
-            <a:ext cx="2138934" cy="420624"/>
-          </a:xfrm>
-          <a:prstGeom prst="roundRect">
-            <a:avLst>
-              <a:gd name="adj" fmla="val 50000"/>
-            </a:avLst>
-          </a:prstGeom>
-          <a:solidFill>
-            <a:srgbClr val="262B3F"/>
-          </a:solidFill>
-          <a:ln>
-            <a:noFill/>
-          </a:ln>
-          <a:effectLst/>
-        </p:spPr>
-        <p:style>
-          <a:lnRef idx="1">
-            <a:schemeClr val="accent1"/>
-          </a:lnRef>
-          <a:fillRef idx="3">
-            <a:schemeClr val="accent1"/>
-          </a:fillRef>
-          <a:effectRef idx="2">
-            <a:schemeClr val="accent1"/>
-          </a:effectRef>
-          <a:fontRef idx="minor">
-            <a:schemeClr val="lt1"/>
-          </a:fontRef>
-        </p:style>
-        <p:txBody>
-          <a:bodyPr rtlCol="0" anchor="ctr" lIns="0" rIns="0" tIns="0" bIns="0" wrap="none"/>
-          <a:lstStyle/>
-          <a:p>
-            <a:pPr algn="ctr"/>
-            <a:r>
-              <a:rPr sz="1400">
-                <a:solidFill>
-                  <a:srgbClr val="FFFFFF"/>
-                </a:solidFill>
-                <a:latin typeface="맑은 고딕"/>
-                <a:ea typeface="맑은 고딕"/>
-                <a:cs typeface="맑은 고딕"/>
-              </a:rPr>
-              <a:t>Blender · 3D 보정</a:t>
-            </a:r>
-          </a:p>
-        </p:txBody>
-      </p:sp>
-      <p:sp>
-        <p:nvSpPr>
-          <p:cNvPr id="28" name="Rounded Rectangle 27"/>
-          <p:cNvSpPr/>
-          <p:nvPr/>
-        </p:nvSpPr>
-        <p:spPr>
-          <a:xfrm>
-            <a:off x="640080" y="5413248"/>
-            <a:ext cx="2761234" cy="420624"/>
-          </a:xfrm>
-          <a:prstGeom prst="roundRect">
-            <a:avLst>
-              <a:gd name="adj" fmla="val 50000"/>
-            </a:avLst>
-          </a:prstGeom>
-          <a:solidFill>
-            <a:srgbClr val="262B3F"/>
-          </a:solidFill>
-          <a:ln>
-            <a:noFill/>
-          </a:ln>
-          <a:effectLst/>
-        </p:spPr>
-        <p:style>
-          <a:lnRef idx="1">
-            <a:schemeClr val="accent1"/>
-          </a:lnRef>
-          <a:fillRef idx="3">
-            <a:schemeClr val="accent1"/>
-          </a:fillRef>
-          <a:effectRef idx="2">
-            <a:schemeClr val="accent1"/>
-          </a:effectRef>
-          <a:fontRef idx="minor">
-            <a:schemeClr val="lt1"/>
-          </a:fontRef>
-        </p:style>
-        <p:txBody>
-          <a:bodyPr rtlCol="0" anchor="ctr" lIns="0" rIns="0" tIns="0" bIns="0" wrap="none"/>
-          <a:lstStyle/>
-          <a:p>
-            <a:pPr algn="ctr"/>
-            <a:r>
-              <a:rPr sz="1400">
-                <a:solidFill>
-                  <a:srgbClr val="FFFFFF"/>
-                </a:solidFill>
-                <a:latin typeface="맑은 고딕"/>
-                <a:ea typeface="맑은 고딕"/>
-                <a:cs typeface="맑은 고딕"/>
-              </a:rPr>
-              <a:t>Claude Code + Unity MCP</a:t>
-            </a:r>
-          </a:p>
-        </p:txBody>
-      </p:sp>
-      <p:sp>
-        <p:nvSpPr>
-          <p:cNvPr id="29" name="Rounded Rectangle 28"/>
-          <p:cNvSpPr/>
-          <p:nvPr/>
-        </p:nvSpPr>
-        <p:spPr>
-          <a:xfrm>
-            <a:off x="3538474" y="5413248"/>
-            <a:ext cx="1098804" cy="420624"/>
-          </a:xfrm>
-          <a:prstGeom prst="roundRect">
-            <a:avLst>
-              <a:gd name="adj" fmla="val 50000"/>
-            </a:avLst>
-          </a:prstGeom>
-          <a:solidFill>
-            <a:srgbClr val="262B3F"/>
-          </a:solidFill>
-          <a:ln>
-            <a:noFill/>
-          </a:ln>
-          <a:effectLst/>
-        </p:spPr>
-        <p:style>
-          <a:lnRef idx="1">
-            <a:schemeClr val="accent1"/>
-          </a:lnRef>
-          <a:fillRef idx="3">
-            <a:schemeClr val="accent1"/>
-          </a:fillRef>
-          <a:effectRef idx="2">
-            <a:schemeClr val="accent1"/>
-          </a:effectRef>
-          <a:fontRef idx="minor">
-            <a:schemeClr val="lt1"/>
-          </a:fontRef>
-        </p:style>
-        <p:txBody>
-          <a:bodyPr rtlCol="0" anchor="ctr" lIns="0" rIns="0" tIns="0" bIns="0" wrap="none"/>
-          <a:lstStyle/>
-          <a:p>
-            <a:pPr algn="ctr"/>
-            <a:r>
-              <a:rPr sz="1400">
-                <a:solidFill>
-                  <a:srgbClr val="FFFFFF"/>
-                </a:solidFill>
-                <a:latin typeface="맑은 고딕"/>
-                <a:ea typeface="맑은 고딕"/>
-                <a:cs typeface="맑은 고딕"/>
-              </a:rPr>
-              <a:t>GitHub</a:t>
-            </a:r>
-          </a:p>
-        </p:txBody>
-      </p:sp>
-      <p:sp>
-        <p:nvSpPr>
-          <p:cNvPr id="30" name="PageNo"/>
-          <p:cNvSpPr txBox="1"/>
-          <p:nvPr/>
-        </p:nvSpPr>
-        <p:spPr>
-          <a:xfrm>
-            <a:off x="10728655" y="6400800"/>
-            <a:ext cx="914400" cy="274320"/>
-          </a:xfrm>
-          <a:prstGeom prst="rect">
-            <a:avLst/>
-          </a:prstGeom>
-          <a:noFill/>
-        </p:spPr>
-        <p:txBody>
-          <a:bodyPr wrap="square" lIns="0" rIns="0" tIns="0" bIns="0" anchor="t">
-            <a:spAutoFit/>
-          </a:bodyPr>
-          <a:lstStyle/>
-          <a:p>
-            <a:pPr algn="r"/>
-            <a:r>
-              <a:rPr sz="1100" b="0">
-                <a:solidFill>
-                  <a:srgbClr val="A3ABBD"/>
-                </a:solidFill>
-                <a:latin typeface="맑은 고딕"/>
-                <a:ea typeface="맑은 고딕"/>
-                <a:cs typeface="맑은 고딕"/>
-              </a:rPr>
-              <a:t>6 / 7</a:t>
+              <a:t>5 / 6</a:t>
             </a:r>
           </a:p>
         </p:txBody>
@@ -9865,7 +8439,7 @@
                 <a:ea typeface="맑은 고딕"/>
                 <a:cs typeface="맑은 고딕"/>
               </a:rPr>
-              <a:t>7 / 7</a:t>
+              <a:t>6 / 6</a:t>
             </a:r>
           </a:p>
         </p:txBody>

</xml_diff>